<commit_message>
Fix caidas count: 28 active marks (fallecido separate), relabel first-call rule
</commit_message>
<xml_diff>
--- a/presentacion_caidas.pptx
+++ b/presentacion_caidas.pptx
@@ -3750,7 +3750,7 @@
                 </a:solidFill>
                 <a:latin typeface="Segoe UI"/>
               </a:rPr>
-              <a:t>8</a:t>
+              <a:t>7</a:t>
             </a:r>
           </a:p>
         </p:txBody>
@@ -4045,46 +4045,6 @@
                 <a:latin typeface="Segoe UI"/>
               </a:rPr>
               <a:t>marca FEVE</a:t>
-            </a:r>
-          </a:p>
-          <a:p>
-            <a:pPr>
-              <a:lnSpc>
-                <a:spcPct val="114000"/>
-              </a:lnSpc>
-              <a:spcBef>
-                <a:spcPts val="0"/>
-              </a:spcBef>
-              <a:spcAft>
-                <a:spcPts val="936"/>
-              </a:spcAft>
-            </a:pPr>
-            <a:r>
-              <a:rPr sz="960" b="1">
-                <a:solidFill>
-                  <a:srgbClr val="1F5130"/>
-                </a:solidFill>
-                <a:latin typeface="Segoe UI"/>
-              </a:rPr>
-              <a:t>•  </a:t>
-            </a:r>
-            <a:r>
-              <a:rPr sz="960" b="1">
-                <a:solidFill>
-                  <a:srgbClr val="1F5130"/>
-                </a:solidFill>
-                <a:latin typeface="Segoe UI"/>
-              </a:rPr>
-              <a:t>Fallecido</a:t>
-            </a:r>
-            <a:r>
-              <a:rPr sz="860" b="0">
-                <a:solidFill>
-                  <a:srgbClr val="5B6F66"/>
-                </a:solidFill>
-                <a:latin typeface="Segoe UI"/>
-              </a:rPr>
-              <a:t>  (filtro aparte)</a:t>
             </a:r>
           </a:p>
         </p:txBody>
@@ -4835,13 +4795,22 @@
               <a:t>•  </a:t>
             </a:r>
             <a:r>
+              <a:rPr sz="960" b="1">
+                <a:solidFill>
+                  <a:srgbClr val="1F5130"/>
+                </a:solidFill>
+                <a:latin typeface="Segoe UI"/>
+              </a:rPr>
+              <a:t>Sin buró</a:t>
+            </a:r>
+            <a:r>
               <a:rPr sz="960" b="0">
                 <a:solidFill>
                   <a:srgbClr val="14271D"/>
                 </a:solidFill>
                 <a:latin typeface="Segoe UI"/>
               </a:rPr>
-              <a:t>Buró </a:t>
+              <a:t> y clasificación </a:t>
             </a:r>
             <a:r>
               <a:rPr sz="960" b="1">
@@ -4859,7 +4828,7 @@
                 </a:solidFill>
                 <a:latin typeface="Segoe UI"/>
               </a:rPr>
-              <a:t> en los últ. 5 meses</a:t>
+              <a:t> (últ. 5 m) · 1ra llamada banc.</a:t>
             </a:r>
           </a:p>
         </p:txBody>
@@ -6358,7 +6327,43 @@
                 </a:solidFill>
                 <a:latin typeface="Segoe UI"/>
               </a:rPr>
-              <a:t>. Las marcas se arman pivoteando la tabla </a:t>
+              <a:t>. Son </a:t>
+            </a:r>
+            <a:r>
+              <a:rPr sz="1100" b="1">
+                <a:solidFill>
+                  <a:srgbClr val="1F5130"/>
+                </a:solidFill>
+                <a:latin typeface="Segoe UI"/>
+              </a:rPr>
+              <a:t>28 marcas activas</a:t>
+            </a:r>
+            <a:r>
+              <a:rPr sz="1100" b="0">
+                <a:solidFill>
+                  <a:srgbClr val="14271D"/>
+                </a:solidFill>
+                <a:latin typeface="Segoe UI"/>
+              </a:rPr>
+              <a:t>; aparte se excluye a los </a:t>
+            </a:r>
+            <a:r>
+              <a:rPr sz="1100" b="1">
+                <a:solidFill>
+                  <a:srgbClr val="1F5130"/>
+                </a:solidFill>
+                <a:latin typeface="Segoe UI"/>
+              </a:rPr>
+              <a:t>fallecidos</a:t>
+            </a:r>
+            <a:r>
+              <a:rPr sz="1100" b="0">
+                <a:solidFill>
+                  <a:srgbClr val="14271D"/>
+                </a:solidFill>
+                <a:latin typeface="Segoe UI"/>
+              </a:rPr>
+              <a:t> con </a:t>
             </a:r>
             <a:r>
               <a:rPr sz="1000" b="0">
@@ -6367,7 +6372,7 @@
                 </a:solidFill>
                 <a:latin typeface="Consolas"/>
               </a:rPr>
-              <a:t>caidas</a:t>
+              <a:t>flg_f = 'Fallecido'</a:t>
             </a:r>
             <a:r>
               <a:rPr sz="1100" b="0">
@@ -6376,43 +6381,7 @@
                 </a:solidFill>
                 <a:latin typeface="Segoe UI"/>
               </a:rPr>
-              <a:t> (una fila por </a:t>
-            </a:r>
-            <a:r>
-              <a:rPr sz="1000" b="0">
-                <a:solidFill>
-                  <a:srgbClr val="26603A"/>
-                </a:solidFill>
-                <a:latin typeface="Consolas"/>
-              </a:rPr>
-              <a:t>descripcion</a:t>
-            </a:r>
-            <a:r>
-              <a:rPr sz="1100" b="0">
-                <a:solidFill>
-                  <a:srgbClr val="14271D"/>
-                </a:solidFill>
-                <a:latin typeface="Segoe UI"/>
-              </a:rPr>
-              <a:t>) con </a:t>
-            </a:r>
-            <a:r>
-              <a:rPr sz="1000" b="0">
-                <a:solidFill>
-                  <a:srgbClr val="26603A"/>
-                </a:solidFill>
-                <a:latin typeface="Consolas"/>
-              </a:rPr>
-              <a:t>MAX(CASE…)</a:t>
-            </a:r>
-            <a:r>
-              <a:rPr sz="1100" b="0">
-                <a:solidFill>
-                  <a:srgbClr val="14271D"/>
-                </a:solidFill>
-                <a:latin typeface="Segoe UI"/>
-              </a:rPr>
-              <a:t> por cliente.</a:t>
+              <a:t> (no es marca de caída).</a:t>
             </a:r>
           </a:p>
         </p:txBody>

</xml_diff>